<commit_message>
fix(beasiswa): resolve TDZ runtime crash caused by pUPActive declaration order
</commit_message>
<xml_diff>
--- a/jempol_amanah_v2-1_FINAL.pptx
+++ b/jempol_amanah_v2-1_FINAL.pptx
@@ -448,7 +448,7 @@
                   </a:defRPr>
                 </a:pPr>
                 <a:r>
-                  <a:rPr sz="1000" b="0" i="0" u="none" strike="noStrike">
+                  <a:rPr lang="id-ID" sz="1000" b="0" i="0" u="none" strike="noStrike">
                     <a:solidFill>
                       <a:srgbClr val="000000"/>
                     </a:solidFill>
@@ -2576,7 +2576,7 @@
         </p:nvSpPr>
         <p:spPr>
           <a:xfrm>
-            <a:off x="0" y="0"/>
+            <a:off x="12970" y="0"/>
             <a:ext cx="9144000" cy="5143500"/>
           </a:xfrm>
           <a:prstGeom prst="rect">
@@ -2939,7 +2939,29 @@
                 <a:ea typeface="Calibri" pitchFamily="34" charset="-122"/>
                 <a:cs typeface="Calibri" pitchFamily="34" charset="-120"/>
               </a:rPr>
-              <a:t>Pemateri: Rieza Eka Tomata, S.Kom</a:t>
+              <a:t>Pemateri: Rieza Eka Toma</a:t>
+            </a:r>
+            <a:r>
+              <a:rPr lang="id-ID" sz="1400" dirty="0">
+                <a:solidFill>
+                  <a:srgbClr val="FFFFFF"/>
+                </a:solidFill>
+                <a:latin typeface="Calibri" pitchFamily="34" charset="0"/>
+                <a:ea typeface="Calibri" pitchFamily="34" charset="-122"/>
+                <a:cs typeface="Calibri" pitchFamily="34" charset="-120"/>
+              </a:rPr>
+              <a:t>r</a:t>
+            </a:r>
+            <a:r>
+              <a:rPr lang="en-US" sz="1400" dirty="0">
+                <a:solidFill>
+                  <a:srgbClr val="FFFFFF"/>
+                </a:solidFill>
+                <a:latin typeface="Calibri" pitchFamily="34" charset="0"/>
+                <a:ea typeface="Calibri" pitchFamily="34" charset="-122"/>
+                <a:cs typeface="Calibri" pitchFamily="34" charset="-120"/>
+              </a:rPr>
+              <a:t>a, S.Kom</a:t>
             </a:r>
             <a:endParaRPr lang="en-US" sz="1400" dirty="0"/>
           </a:p>

</xml_diff>